<commit_message>
fix: move system steps into portal lane in BPMN for user story 4.1.1
</commit_message>
<xml_diff>
--- a/D2D User Story/7_Dimensions_Erstpruefer_Themenfreigabe.pptx
+++ b/D2D User Story/7_Dimensions_Erstpruefer_Themenfreigabe.pptx
@@ -551,7 +551,7 @@
           <a:p>
             <a:r>
               <a:rPr lang="en-US" dirty="0"/>
-              <a:t>BPMN-Ausschnitt nur für US 4.1.1. Start: Antrag vom Prüfungsausschuss angenommen (US 3.2.1); Erstprüfer:in wird informiert (US 3.2.3). Der Nein-Zweig stammt aus dem Aktivitätsdiagramm des Teams (1. Prüfer:in: Änderungswunsch oder Ablehnung eintragen, danach Rückfrage, Studierende:r passt den Antrag an) und aus dem Formularfeld Bestätigung der Vorschläge des Kandidaten: Nein (siehe Anlage). Die Vorlesung nutzt für Abläufe UML-Aktivitätsdiagramme; BPMN wurde auf Wunsch des Teams gewählt. Editierbare Quelle: quellen/Action_Themenfreigabe.bpmn.</a:t>
+              <a:t>BPMN-Ausschnitt nur für US 4.1.1. Start: Die oder der Studierende hat den Antrag mit Thema eingereicht; das Portal informiert die Erstprüfer:in. Erstprüfer:in ruft das Thema auf und prüft es. Ja-Zweig: Thema bestätigen und freigeben, das Portal speichert die Themenfreigabe und leitet den Antrag weiter (Regel C6). Nein-Zweig: Erstprüfer:in trägt einen Änderungswunsch ein, das Portal speichert ihn und informiert die Studierende:n. Systemschritte liegen in der Lane Portal, Endereignisse sind als Zustände benannt. Editierbare Quelle: quellen/Action_Themenfreigabe.bpmn.</a:t>
             </a:r>
           </a:p>
         </p:txBody>
@@ -4783,7 +4783,6 @@
         <a:solidFill>
           <a:srgbClr val="FFFFFF"/>
         </a:solidFill>
-        <a:effectLst/>
       </p:bgPr>
     </p:bg>
     <p:spTree>
@@ -4821,7 +4820,7 @@
           <a:bodyPr wrap="square" lIns="0" tIns="0" rIns="0" bIns="0" rtlCol="0" anchor="ctr"/>
           <a:lstStyle/>
           <a:p>
-            <a:pPr marL="0" indent="0">
+            <a:pPr indent="0" marL="0">
               <a:buNone/>
             </a:pPr>
             <a:r>
@@ -4860,11 +4859,11 @@
           <a:bodyPr wrap="square" lIns="0" tIns="0" rIns="0" bIns="0" rtlCol="0" anchor="ctr"/>
           <a:lstStyle/>
           <a:p>
-            <a:pPr marL="0" indent="0" algn="r">
-              <a:buNone/>
-            </a:pPr>
-            <a:r>
-              <a:rPr lang="en-US" sz="800" b="1" kern="0" spc="150" dirty="0">
+            <a:pPr algn="r" indent="0" marL="0">
+              <a:buNone/>
+            </a:pPr>
+            <a:r>
+              <a:rPr lang="en-US" sz="800" b="1" spc="150" kern="0" dirty="0">
                 <a:solidFill>
                   <a:srgbClr val="97BC62"/>
                 </a:solidFill>
@@ -4899,7 +4898,7 @@
           <a:bodyPr wrap="square" lIns="0" tIns="0" rIns="0" bIns="0" rtlCol="0" anchor="t"/>
           <a:lstStyle/>
           <a:p>
-            <a:pPr marL="0" indent="0">
+            <a:pPr indent="0" marL="0">
               <a:buNone/>
             </a:pPr>
             <a:r>
@@ -4938,7 +4937,7 @@
           <a:bodyPr wrap="square" lIns="0" tIns="0" rIns="0" bIns="0" rtlCol="0" anchor="t"/>
           <a:lstStyle/>
           <a:p>
-            <a:pPr marL="0" indent="0">
+            <a:pPr indent="0" marL="0">
               <a:buNone/>
             </a:pPr>
             <a:r>
@@ -4977,7 +4976,7 @@
           <a:bodyPr wrap="square" lIns="0" tIns="0" rIns="0" bIns="0" rtlCol="0" anchor="t"/>
           <a:lstStyle/>
           <a:p>
-            <a:pPr marL="0" indent="0" algn="r">
+            <a:pPr algn="r" indent="0" marL="0">
               <a:buNone/>
             </a:pPr>
             <a:r>
@@ -5004,7 +5003,7 @@
         <p:spPr>
           <a:xfrm>
             <a:off x="411480" y="987552"/>
-            <a:ext cx="8321040" cy="3108960"/>
+            <a:ext cx="8321040" cy="3154680"/>
           </a:xfrm>
           <a:prstGeom prst="rect">
             <a:avLst/>
@@ -5029,7 +5028,7 @@
         <p:spPr>
           <a:xfrm>
             <a:off x="411480" y="987552"/>
-            <a:ext cx="274320" cy="3108960"/>
+            <a:ext cx="274320" cy="3154680"/>
           </a:xfrm>
           <a:prstGeom prst="rect">
             <a:avLst/>
@@ -5079,7 +5078,7 @@
         <p:spPr>
           <a:xfrm>
             <a:off x="685800" y="2770632"/>
-            <a:ext cx="274320" cy="1325880"/>
+            <a:ext cx="274320" cy="1371600"/>
           </a:xfrm>
           <a:prstGeom prst="rect">
             <a:avLst/>
@@ -5126,8 +5125,8 @@
         </p:nvSpPr>
         <p:spPr>
           <a:xfrm rot="16200000">
-            <a:off x="-1005840" y="2404872"/>
-            <a:ext cx="3108960" cy="274320"/>
+            <a:off x="-1028700" y="2427732"/>
+            <a:ext cx="3154680" cy="274320"/>
           </a:xfrm>
           <a:prstGeom prst="rect">
             <a:avLst/>
@@ -5139,7 +5138,7 @@
           <a:bodyPr wrap="square" lIns="0" tIns="0" rIns="0" bIns="0" rtlCol="0" anchor="ctr"/>
           <a:lstStyle/>
           <a:p>
-            <a:pPr marL="0" indent="0" algn="ctr">
+            <a:pPr algn="ctr" indent="0" marL="0">
               <a:buNone/>
             </a:pPr>
             <a:r>
@@ -5178,7 +5177,7 @@
           <a:bodyPr wrap="square" lIns="0" tIns="0" rIns="0" bIns="0" rtlCol="0" anchor="ctr"/>
           <a:lstStyle/>
           <a:p>
-            <a:pPr marL="0" indent="0" algn="ctr">
+            <a:pPr algn="ctr" indent="0" marL="0">
               <a:buNone/>
             </a:pPr>
             <a:r>
@@ -5204,8 +5203,8 @@
         </p:nvSpPr>
         <p:spPr>
           <a:xfrm rot="16200000">
-            <a:off x="160020" y="3296412"/>
-            <a:ext cx="1325880" cy="274320"/>
+            <a:off x="137160" y="3319272"/>
+            <a:ext cx="1371600" cy="274320"/>
           </a:xfrm>
           <a:prstGeom prst="rect">
             <a:avLst/>
@@ -5217,7 +5216,7 @@
           <a:bodyPr wrap="square" lIns="0" tIns="0" rIns="0" bIns="0" rtlCol="0" anchor="ctr"/>
           <a:lstStyle/>
           <a:p>
-            <a:pPr marL="0" indent="0" algn="ctr">
+            <a:pPr algn="ctr" indent="0" marL="0">
               <a:buNone/>
             </a:pPr>
             <a:r>
@@ -5243,7 +5242,7 @@
         </p:nvSpPr>
         <p:spPr>
           <a:xfrm>
-            <a:off x="1188720" y="3209544"/>
+            <a:off x="1115568" y="3145536"/>
             <a:ext cx="256032" cy="256032"/>
           </a:xfrm>
           <a:prstGeom prst="ellipse">
@@ -5268,8 +5267,8 @@
         </p:nvSpPr>
         <p:spPr>
           <a:xfrm>
-            <a:off x="1078992" y="3520440"/>
-            <a:ext cx="868680" cy="411480"/>
+            <a:off x="1024128" y="3657600"/>
+            <a:ext cx="1097280" cy="329184"/>
           </a:xfrm>
           <a:prstGeom prst="rect">
             <a:avLst/>
@@ -5281,24 +5280,19 @@
           <a:bodyPr wrap="square" lIns="0" tIns="0" rIns="0" bIns="0" rtlCol="0" anchor="t"/>
           <a:lstStyle/>
           <a:p>
-            <a:pPr marL="0" indent="0" algn="l">
-              <a:buNone/>
-            </a:pPr>
-            <a:r>
-              <a:rPr lang="en-US" sz="700" dirty="0"/>
-              <a:t>Student </a:t>
-            </a:r>
-            <a:r>
-              <a:rPr lang="en-US" sz="700" dirty="0" err="1"/>
-              <a:t>schickt</a:t>
-            </a:r>
-            <a:r>
-              <a:rPr lang="en-US" sz="700" dirty="0"/>
-              <a:t> thema an </a:t>
-            </a:r>
-            <a:r>
-              <a:rPr lang="en-US" sz="700" dirty="0" err="1"/>
-              <a:t>Prüfer</a:t>
+            <a:pPr algn="l" indent="0" marL="0">
+              <a:buNone/>
+            </a:pPr>
+            <a:r>
+              <a:rPr lang="en-US" sz="700" dirty="0">
+                <a:solidFill>
+                  <a:srgbClr val="5C6B5C"/>
+                </a:solidFill>
+                <a:latin typeface="Calibri" pitchFamily="34" charset="0"/>
+                <a:ea typeface="Calibri" pitchFamily="34" charset="-122"/>
+                <a:cs typeface="Calibri" pitchFamily="34" charset="-120"/>
+              </a:rPr>
+              <a:t>Thema von Studierende:r eingereicht</a:t>
             </a:r>
             <a:endParaRPr lang="en-US" sz="700" dirty="0"/>
           </a:p>
@@ -5312,8 +5306,8 @@
         </p:nvSpPr>
         <p:spPr>
           <a:xfrm>
-            <a:off x="1444752" y="3337560"/>
-            <a:ext cx="521208" cy="914"/>
+            <a:off x="1371600" y="3273552"/>
+            <a:ext cx="228600" cy="914"/>
           </a:xfrm>
           <a:prstGeom prst="line">
             <a:avLst/>
@@ -5336,7 +5330,7 @@
         </p:nvSpPr>
         <p:spPr>
           <a:xfrm>
-            <a:off x="1965960" y="3099816"/>
+            <a:off x="1600200" y="3035808"/>
             <a:ext cx="1188720" cy="475488"/>
           </a:xfrm>
           <a:prstGeom prst="roundRect">
@@ -5363,7 +5357,7 @@
         </p:nvSpPr>
         <p:spPr>
           <a:xfrm>
-            <a:off x="2011680" y="3099816"/>
+            <a:off x="1645920" y="3035808"/>
             <a:ext cx="1097280" cy="475488"/>
           </a:xfrm>
           <a:prstGeom prst="rect">
@@ -5376,7 +5370,7 @@
           <a:bodyPr wrap="square" lIns="0" tIns="0" rIns="0" bIns="0" rtlCol="0" anchor="ctr"/>
           <a:lstStyle/>
           <a:p>
-            <a:pPr marL="0" indent="0" algn="ctr">
+            <a:pPr algn="ctr" indent="0" marL="0">
               <a:buNone/>
             </a:pPr>
             <a:r>
@@ -5402,8 +5396,8 @@
         </p:nvSpPr>
         <p:spPr>
           <a:xfrm>
-            <a:off x="2560320" y="2414016"/>
-            <a:ext cx="914" cy="685800"/>
+            <a:off x="2194560" y="2414016"/>
+            <a:ext cx="914" cy="621792"/>
           </a:xfrm>
           <a:prstGeom prst="line">
             <a:avLst/>
@@ -5426,7 +5420,7 @@
         </p:nvSpPr>
         <p:spPr>
           <a:xfrm>
-            <a:off x="1965960" y="1938528"/>
+            <a:off x="1600200" y="1938528"/>
             <a:ext cx="1188720" cy="475488"/>
           </a:xfrm>
           <a:prstGeom prst="roundRect">
@@ -5453,7 +5447,7 @@
         </p:nvSpPr>
         <p:spPr>
           <a:xfrm>
-            <a:off x="2011680" y="1938528"/>
+            <a:off x="1645920" y="1938528"/>
             <a:ext cx="1097280" cy="475488"/>
           </a:xfrm>
           <a:prstGeom prst="rect">
@@ -5466,7 +5460,7 @@
           <a:bodyPr wrap="square" lIns="0" tIns="0" rIns="0" bIns="0" rtlCol="0" anchor="ctr"/>
           <a:lstStyle/>
           <a:p>
-            <a:pPr marL="0" indent="0" algn="ctr">
+            <a:pPr algn="ctr" indent="0" marL="0">
               <a:buNone/>
             </a:pPr>
             <a:r>
@@ -5492,8 +5486,8 @@
         </p:nvSpPr>
         <p:spPr>
           <a:xfrm>
-            <a:off x="3154680" y="2176272"/>
-            <a:ext cx="274320" cy="914"/>
+            <a:off x="2788920" y="2176272"/>
+            <a:ext cx="228600" cy="914"/>
           </a:xfrm>
           <a:prstGeom prst="line">
             <a:avLst/>
@@ -5516,7 +5510,7 @@
         </p:nvSpPr>
         <p:spPr>
           <a:xfrm>
-            <a:off x="3429000" y="1938528"/>
+            <a:off x="3017520" y="1938528"/>
             <a:ext cx="1188720" cy="475488"/>
           </a:xfrm>
           <a:prstGeom prst="roundRect">
@@ -5543,7 +5537,7 @@
         </p:nvSpPr>
         <p:spPr>
           <a:xfrm>
-            <a:off x="3474720" y="1938528"/>
+            <a:off x="3063240" y="1938528"/>
             <a:ext cx="1097280" cy="475488"/>
           </a:xfrm>
           <a:prstGeom prst="rect">
@@ -5556,7 +5550,7 @@
           <a:bodyPr wrap="square" lIns="0" tIns="0" rIns="0" bIns="0" rtlCol="0" anchor="ctr"/>
           <a:lstStyle/>
           <a:p>
-            <a:pPr marL="0" indent="0" algn="ctr">
+            <a:pPr algn="ctr" indent="0" marL="0">
               <a:buNone/>
             </a:pPr>
             <a:r>
@@ -5582,8 +5576,8 @@
         </p:nvSpPr>
         <p:spPr>
           <a:xfrm>
-            <a:off x="4617720" y="2176272"/>
-            <a:ext cx="118872" cy="914"/>
+            <a:off x="4206240" y="2176272"/>
+            <a:ext cx="146304" cy="914"/>
           </a:xfrm>
           <a:prstGeom prst="line">
             <a:avLst/>
@@ -5606,7 +5600,7 @@
         </p:nvSpPr>
         <p:spPr>
           <a:xfrm>
-            <a:off x="4736592" y="1975104"/>
+            <a:off x="4352544" y="1975104"/>
             <a:ext cx="402336" cy="402336"/>
           </a:xfrm>
           <a:prstGeom prst="diamond">
@@ -5631,7 +5625,7 @@
         </p:nvSpPr>
         <p:spPr>
           <a:xfrm>
-            <a:off x="4736592" y="1975104"/>
+            <a:off x="4352544" y="1975104"/>
             <a:ext cx="402336" cy="402336"/>
           </a:xfrm>
           <a:prstGeom prst="rect">
@@ -5644,7 +5638,7 @@
           <a:bodyPr wrap="square" lIns="0" tIns="0" rIns="0" bIns="0" rtlCol="0" anchor="ctr"/>
           <a:lstStyle/>
           <a:p>
-            <a:pPr marL="0" indent="0" algn="ctr">
+            <a:pPr algn="ctr" indent="0" marL="0">
               <a:buNone/>
             </a:pPr>
             <a:r>
@@ -5670,7 +5664,7 @@
         </p:nvSpPr>
         <p:spPr>
           <a:xfrm>
-            <a:off x="4251960" y="2404872"/>
+            <a:off x="3867912" y="2404872"/>
             <a:ext cx="1371600" cy="182880"/>
           </a:xfrm>
           <a:prstGeom prst="rect">
@@ -5683,11 +5677,11 @@
           <a:bodyPr wrap="square" lIns="0" tIns="0" rIns="0" bIns="0" rtlCol="0" anchor="t"/>
           <a:lstStyle/>
           <a:p>
-            <a:pPr marL="0" indent="0" algn="ctr">
-              <a:buNone/>
-            </a:pPr>
-            <a:r>
-              <a:rPr lang="en-US" sz="750" i="1" dirty="0" err="1">
+            <a:pPr algn="ctr" indent="0" marL="0">
+              <a:buNone/>
+            </a:pPr>
+            <a:r>
+              <a:rPr lang="en-US" sz="750" i="1" dirty="0">
                 <a:solidFill>
                   <a:srgbClr val="5C6B5C"/>
                 </a:solidFill>
@@ -5695,18 +5689,7 @@
                 <a:ea typeface="Calibri" pitchFamily="34" charset="-122"/>
                 <a:cs typeface="Calibri" pitchFamily="34" charset="-120"/>
               </a:rPr>
-              <a:t>Passt</a:t>
-            </a:r>
-            <a:r>
-              <a:rPr lang="en-US" sz="750" i="1" dirty="0">
-                <a:solidFill>
-                  <a:srgbClr val="5C6B5C"/>
-                </a:solidFill>
-                <a:latin typeface="Calibri" pitchFamily="34" charset="0"/>
-                <a:ea typeface="Calibri" pitchFamily="34" charset="-122"/>
-                <a:cs typeface="Calibri" pitchFamily="34" charset="-120"/>
-              </a:rPr>
-              <a:t> das Thema?</a:t>
+              <a:t>Thema wie abgestimmt?</a:t>
             </a:r>
             <a:endParaRPr lang="en-US" sz="750" dirty="0"/>
           </a:p>
@@ -5720,8 +5703,8 @@
         </p:nvSpPr>
         <p:spPr>
           <a:xfrm>
-            <a:off x="5138928" y="2176272"/>
-            <a:ext cx="301752" cy="914"/>
+            <a:off x="4754880" y="2176272"/>
+            <a:ext cx="182880" cy="914"/>
           </a:xfrm>
           <a:prstGeom prst="line">
             <a:avLst/>
@@ -5744,8 +5727,8 @@
         </p:nvSpPr>
         <p:spPr>
           <a:xfrm>
-            <a:off x="5157216" y="1993392"/>
-            <a:ext cx="274320" cy="164592"/>
+            <a:off x="4736592" y="1993392"/>
+            <a:ext cx="182880" cy="164592"/>
           </a:xfrm>
           <a:prstGeom prst="rect">
             <a:avLst/>
@@ -5757,7 +5740,7 @@
           <a:bodyPr wrap="square" lIns="0" tIns="0" rIns="0" bIns="0" rtlCol="0" anchor="t"/>
           <a:lstStyle/>
           <a:p>
-            <a:pPr marL="0" indent="0">
+            <a:pPr indent="0" marL="0">
               <a:buNone/>
             </a:pPr>
             <a:r>
@@ -5783,7 +5766,7 @@
         </p:nvSpPr>
         <p:spPr>
           <a:xfrm>
-            <a:off x="5440680" y="1938528"/>
+            <a:off x="4937760" y="1938528"/>
             <a:ext cx="1188720" cy="475488"/>
           </a:xfrm>
           <a:prstGeom prst="roundRect">
@@ -5810,7 +5793,7 @@
         </p:nvSpPr>
         <p:spPr>
           <a:xfrm>
-            <a:off x="5486400" y="1938528"/>
+            <a:off x="4983480" y="1938528"/>
             <a:ext cx="1097280" cy="475488"/>
           </a:xfrm>
           <a:prstGeom prst="rect">
@@ -5823,7 +5806,7 @@
           <a:bodyPr wrap="square" lIns="0" tIns="0" rIns="0" bIns="0" rtlCol="0" anchor="ctr"/>
           <a:lstStyle/>
           <a:p>
-            <a:pPr marL="0" indent="0" algn="ctr">
+            <a:pPr algn="ctr" indent="0" marL="0">
               <a:buNone/>
             </a:pPr>
             <a:r>
@@ -5849,8 +5832,8 @@
         </p:nvSpPr>
         <p:spPr>
           <a:xfrm>
-            <a:off x="6035040" y="2414016"/>
-            <a:ext cx="914" cy="685800"/>
+            <a:off x="5532120" y="2414016"/>
+            <a:ext cx="914" cy="512064"/>
           </a:xfrm>
           <a:prstGeom prst="line">
             <a:avLst/>
@@ -5873,12 +5856,12 @@
         </p:nvSpPr>
         <p:spPr>
           <a:xfrm>
-            <a:off x="5440680" y="3099816"/>
-            <a:ext cx="1188720" cy="475488"/>
+            <a:off x="4937760" y="2926080"/>
+            <a:ext cx="1188720" cy="694944"/>
           </a:xfrm>
           <a:prstGeom prst="roundRect">
             <a:avLst>
-              <a:gd name="adj" fmla="val 19231"/>
+              <a:gd name="adj" fmla="val 13158"/>
             </a:avLst>
           </a:prstGeom>
           <a:solidFill>
@@ -5900,8 +5883,8 @@
         </p:nvSpPr>
         <p:spPr>
           <a:xfrm>
-            <a:off x="5486400" y="3099816"/>
-            <a:ext cx="1097280" cy="475488"/>
+            <a:off x="4983480" y="2926080"/>
+            <a:ext cx="1097280" cy="694944"/>
           </a:xfrm>
           <a:prstGeom prst="rect">
             <a:avLst/>
@@ -5913,7 +5896,7 @@
           <a:bodyPr wrap="square" lIns="0" tIns="0" rIns="0" bIns="0" rtlCol="0" anchor="ctr"/>
           <a:lstStyle/>
           <a:p>
-            <a:pPr marL="0" indent="0" algn="ctr">
+            <a:pPr algn="ctr" indent="0" marL="0">
               <a:buNone/>
             </a:pPr>
             <a:r>
@@ -5925,7 +5908,7 @@
                 <a:ea typeface="Calibri" pitchFamily="34" charset="-122"/>
                 <a:cs typeface="Calibri" pitchFamily="34" charset="-120"/>
               </a:rPr>
-              <a:t>Themenfreigabe speichern</a:t>
+              <a:t>Themenfreigabe speichern, Antrag weiterleiten</a:t>
             </a:r>
             <a:endParaRPr lang="en-US" sz="850" dirty="0"/>
           </a:p>
@@ -5939,8 +5922,8 @@
         </p:nvSpPr>
         <p:spPr>
           <a:xfrm>
-            <a:off x="6629400" y="3337560"/>
-            <a:ext cx="457200" cy="914"/>
+            <a:off x="6126480" y="3273552"/>
+            <a:ext cx="182880" cy="914"/>
           </a:xfrm>
           <a:prstGeom prst="line">
             <a:avLst/>
@@ -5963,7 +5946,7 @@
         </p:nvSpPr>
         <p:spPr>
           <a:xfrm>
-            <a:off x="7086600" y="3200400"/>
+            <a:off x="6309360" y="3136392"/>
             <a:ext cx="274320" cy="274320"/>
           </a:xfrm>
           <a:prstGeom prst="ellipse">
@@ -5988,8 +5971,8 @@
         </p:nvSpPr>
         <p:spPr>
           <a:xfrm>
-            <a:off x="7452360" y="3200400"/>
-            <a:ext cx="1234440" cy="274320"/>
+            <a:off x="5943600" y="3694176"/>
+            <a:ext cx="1005840" cy="182880"/>
           </a:xfrm>
           <a:prstGeom prst="rect">
             <a:avLst/>
@@ -6001,11 +5984,11 @@
           <a:bodyPr wrap="square" lIns="0" tIns="0" rIns="0" bIns="0" rtlCol="0" anchor="ctr"/>
           <a:lstStyle/>
           <a:p>
-            <a:pPr marL="0" indent="0">
-              <a:buNone/>
-            </a:pPr>
-            <a:r>
-              <a:rPr lang="en-US" sz="800" b="1" dirty="0">
+            <a:pPr algn="ctr" indent="0" marL="0">
+              <a:buNone/>
+            </a:pPr>
+            <a:r>
+              <a:rPr lang="en-US" sz="750" b="1" dirty="0">
                 <a:solidFill>
                   <a:srgbClr val="1F2A1F"/>
                 </a:solidFill>
@@ -6015,7 +5998,7 @@
               </a:rPr>
               <a:t>Thema freigegeben</a:t>
             </a:r>
-            <a:endParaRPr lang="en-US" sz="800" dirty="0"/>
+            <a:endParaRPr lang="en-US" sz="750" dirty="0"/>
           </a:p>
         </p:txBody>
       </p:sp>
@@ -6027,7 +6010,7 @@
         </p:nvSpPr>
         <p:spPr>
           <a:xfrm>
-            <a:off x="4937760" y="1444752"/>
+            <a:off x="4553712" y="1444752"/>
             <a:ext cx="914" cy="530352"/>
           </a:xfrm>
           <a:prstGeom prst="line">
@@ -6050,8 +6033,8 @@
         </p:nvSpPr>
         <p:spPr>
           <a:xfrm>
-            <a:off x="4937760" y="1444752"/>
-            <a:ext cx="502920" cy="914"/>
+            <a:off x="4553712" y="1444752"/>
+            <a:ext cx="2258568" cy="914"/>
           </a:xfrm>
           <a:prstGeom prst="line">
             <a:avLst/>
@@ -6074,7 +6057,7 @@
         </p:nvSpPr>
         <p:spPr>
           <a:xfrm>
-            <a:off x="4983480" y="1261872"/>
+            <a:off x="4599432" y="1261872"/>
             <a:ext cx="365760" cy="164592"/>
           </a:xfrm>
           <a:prstGeom prst="rect">
@@ -6087,7 +6070,7 @@
           <a:bodyPr wrap="square" lIns="0" tIns="0" rIns="0" bIns="0" rtlCol="0" anchor="t"/>
           <a:lstStyle/>
           <a:p>
-            <a:pPr marL="0" indent="0">
+            <a:pPr indent="0" marL="0">
               <a:buNone/>
             </a:pPr>
             <a:r>
@@ -6113,7 +6096,7 @@
         </p:nvSpPr>
         <p:spPr>
           <a:xfrm>
-            <a:off x="5440680" y="1207008"/>
+            <a:off x="6812280" y="1207008"/>
             <a:ext cx="1188720" cy="475488"/>
           </a:xfrm>
           <a:prstGeom prst="roundRect">
@@ -6140,7 +6123,7 @@
         </p:nvSpPr>
         <p:spPr>
           <a:xfrm>
-            <a:off x="5486400" y="1207008"/>
+            <a:off x="6858000" y="1207008"/>
             <a:ext cx="1097280" cy="475488"/>
           </a:xfrm>
           <a:prstGeom prst="rect">
@@ -6153,7 +6136,7 @@
           <a:bodyPr wrap="square" lIns="0" tIns="0" rIns="0" bIns="0" rtlCol="0" anchor="ctr"/>
           <a:lstStyle/>
           <a:p>
-            <a:pPr marL="0" indent="0" algn="ctr">
+            <a:pPr algn="ctr" indent="0" marL="0">
               <a:buNone/>
             </a:pPr>
             <a:r>
@@ -6179,8 +6162,8 @@
         </p:nvSpPr>
         <p:spPr>
           <a:xfrm>
-            <a:off x="6629400" y="1444752"/>
-            <a:ext cx="457200" cy="914"/>
+            <a:off x="7406640" y="1682496"/>
+            <a:ext cx="914" cy="1243584"/>
           </a:xfrm>
           <a:prstGeom prst="line">
             <a:avLst/>
@@ -6203,7 +6186,97 @@
         </p:nvSpPr>
         <p:spPr>
           <a:xfrm>
-            <a:off x="7086600" y="1307592"/>
+            <a:off x="6812280" y="2926080"/>
+            <a:ext cx="1188720" cy="694944"/>
+          </a:xfrm>
+          <a:prstGeom prst="roundRect">
+            <a:avLst>
+              <a:gd name="adj" fmla="val 13158"/>
+            </a:avLst>
+          </a:prstGeom>
+          <a:solidFill>
+            <a:srgbClr val="FFFFFF"/>
+          </a:solidFill>
+          <a:ln w="15875">
+            <a:solidFill>
+              <a:srgbClr val="1F2A1F"/>
+            </a:solidFill>
+            <a:prstDash val="solid"/>
+          </a:ln>
+        </p:spPr>
+      </p:sp>
+      <p:sp>
+        <p:nvSpPr>
+          <p:cNvPr id="47" name="Text 45"/>
+          <p:cNvSpPr txBox="1"/>
+          <p:nvPr/>
+        </p:nvSpPr>
+        <p:spPr>
+          <a:xfrm>
+            <a:off x="6858000" y="2926080"/>
+            <a:ext cx="1097280" cy="694944"/>
+          </a:xfrm>
+          <a:prstGeom prst="rect">
+            <a:avLst/>
+          </a:prstGeom>
+          <a:noFill/>
+          <a:ln/>
+        </p:spPr>
+        <p:txBody>
+          <a:bodyPr wrap="square" lIns="0" tIns="0" rIns="0" bIns="0" rtlCol="0" anchor="ctr"/>
+          <a:lstStyle/>
+          <a:p>
+            <a:pPr algn="ctr" indent="0" marL="0">
+              <a:buNone/>
+            </a:pPr>
+            <a:r>
+              <a:rPr lang="en-US" sz="850" dirty="0">
+                <a:solidFill>
+                  <a:srgbClr val="1F2A1F"/>
+                </a:solidFill>
+                <a:latin typeface="Calibri" pitchFamily="34" charset="0"/>
+                <a:ea typeface="Calibri" pitchFamily="34" charset="-122"/>
+                <a:cs typeface="Calibri" pitchFamily="34" charset="-120"/>
+              </a:rPr>
+              <a:t>Änderungswunsch speichern, Studierende:n informieren</a:t>
+            </a:r>
+            <a:endParaRPr lang="en-US" sz="850" dirty="0"/>
+          </a:p>
+        </p:txBody>
+      </p:sp>
+      <p:sp>
+        <p:nvSpPr>
+          <p:cNvPr id="48" name="Shape 46"/>
+          <p:cNvSpPr/>
+          <p:nvPr/>
+        </p:nvSpPr>
+        <p:spPr>
+          <a:xfrm>
+            <a:off x="8001000" y="3273552"/>
+            <a:ext cx="182880" cy="914"/>
+          </a:xfrm>
+          <a:prstGeom prst="line">
+            <a:avLst/>
+          </a:prstGeom>
+          <a:noFill/>
+          <a:ln w="15875">
+            <a:solidFill>
+              <a:srgbClr val="1F2A1F"/>
+            </a:solidFill>
+            <a:prstDash val="solid"/>
+            <a:tailEnd type="triangle"/>
+          </a:ln>
+        </p:spPr>
+      </p:sp>
+      <p:sp>
+        <p:nvSpPr>
+          <p:cNvPr id="49" name="Shape 47"/>
+          <p:cNvSpPr/>
+          <p:nvPr/>
+        </p:nvSpPr>
+        <p:spPr>
+          <a:xfrm>
+            <a:off x="8183880" y="3136392"/>
             <a:ext cx="274320" cy="274320"/>
           </a:xfrm>
           <a:prstGeom prst="ellipse">
@@ -6222,14 +6295,14 @@
       </p:sp>
       <p:sp>
         <p:nvSpPr>
-          <p:cNvPr id="47" name="Text 45"/>
-          <p:cNvSpPr txBox="1"/>
-          <p:nvPr/>
-        </p:nvSpPr>
-        <p:spPr>
-          <a:xfrm>
-            <a:off x="7452360" y="1261872"/>
-            <a:ext cx="1234440" cy="365760"/>
+          <p:cNvPr id="50" name="Text 48"/>
+          <p:cNvSpPr txBox="1"/>
+          <p:nvPr/>
+        </p:nvSpPr>
+        <p:spPr>
+          <a:xfrm>
+            <a:off x="7452360" y="3694176"/>
+            <a:ext cx="1051560" cy="182880"/>
           </a:xfrm>
           <a:prstGeom prst="rect">
             <a:avLst/>
@@ -6241,11 +6314,11 @@
           <a:bodyPr wrap="square" lIns="0" tIns="0" rIns="0" bIns="0" rtlCol="0" anchor="ctr"/>
           <a:lstStyle/>
           <a:p>
-            <a:pPr marL="0" indent="0">
-              <a:buNone/>
-            </a:pPr>
-            <a:r>
-              <a:rPr lang="en-US" sz="800" b="1" dirty="0">
+            <a:pPr algn="r" indent="0" marL="0">
+              <a:buNone/>
+            </a:pPr>
+            <a:r>
+              <a:rPr lang="en-US" sz="750" b="1" dirty="0">
                 <a:solidFill>
                   <a:srgbClr val="1F2A1F"/>
                 </a:solidFill>
@@ -6253,60 +6326,26 @@
                 <a:ea typeface="Calibri" pitchFamily="34" charset="-122"/>
                 <a:cs typeface="Calibri" pitchFamily="34" charset="-120"/>
               </a:rPr>
-              <a:t>Rückfrage an </a:t>
-            </a:r>
-            <a:r>
-              <a:rPr lang="en-US" sz="800" b="1" dirty="0" err="1">
-                <a:solidFill>
-                  <a:srgbClr val="1F2A1F"/>
-                </a:solidFill>
-                <a:latin typeface="Calibri" pitchFamily="34" charset="0"/>
-                <a:ea typeface="Calibri" pitchFamily="34" charset="-122"/>
-                <a:cs typeface="Calibri" pitchFamily="34" charset="-120"/>
-              </a:rPr>
-              <a:t>Studierende:n</a:t>
-            </a:r>
-            <a:endParaRPr lang="en-US" sz="800" b="1" dirty="0">
-              <a:solidFill>
-                <a:srgbClr val="1F2A1F"/>
-              </a:solidFill>
-              <a:latin typeface="Calibri" pitchFamily="34" charset="0"/>
-              <a:ea typeface="Calibri" pitchFamily="34" charset="-122"/>
-              <a:cs typeface="Calibri" pitchFamily="34" charset="-120"/>
-            </a:endParaRPr>
-          </a:p>
-          <a:p>
-            <a:pPr marL="0" indent="0">
-              <a:buNone/>
-            </a:pPr>
-            <a:r>
-              <a:rPr lang="en-US" sz="800" b="1" dirty="0" err="1">
-                <a:solidFill>
-                  <a:srgbClr val="1F2A1F"/>
-                </a:solidFill>
-                <a:latin typeface="Calibri" pitchFamily="34" charset="0"/>
-                <a:cs typeface="Calibri" pitchFamily="34" charset="-120"/>
-              </a:rPr>
-              <a:t>senden</a:t>
-            </a:r>
-            <a:endParaRPr lang="en-US" sz="800" dirty="0"/>
-          </a:p>
-        </p:txBody>
-      </p:sp>
-      <p:sp>
-        <p:nvSpPr>
-          <p:cNvPr id="48" name="Shape 46"/>
+              <a:t>Rückfrage gesendet</a:t>
+            </a:r>
+            <a:endParaRPr lang="en-US" sz="750" dirty="0"/>
+          </a:p>
+        </p:txBody>
+      </p:sp>
+      <p:sp>
+        <p:nvSpPr>
+          <p:cNvPr id="51" name="Shape 49"/>
           <p:cNvSpPr/>
           <p:nvPr/>
         </p:nvSpPr>
         <p:spPr>
           <a:xfrm>
-            <a:off x="411480" y="4224528"/>
-            <a:ext cx="8321040" cy="457200"/>
+            <a:off x="411480" y="4270248"/>
+            <a:ext cx="8321040" cy="420624"/>
           </a:xfrm>
           <a:prstGeom prst="roundRect">
             <a:avLst>
-              <a:gd name="adj" fmla="val 16000"/>
+              <a:gd name="adj" fmla="val 17391"/>
             </a:avLst>
           </a:prstGeom>
           <a:solidFill>
@@ -6322,14 +6361,14 @@
       </p:sp>
       <p:sp>
         <p:nvSpPr>
-          <p:cNvPr id="49" name="Text 47"/>
-          <p:cNvSpPr txBox="1"/>
-          <p:nvPr/>
-        </p:nvSpPr>
-        <p:spPr>
-          <a:xfrm>
-            <a:off x="521208" y="4224528"/>
-            <a:ext cx="8101584" cy="457200"/>
+          <p:cNvPr id="52" name="Text 50"/>
+          <p:cNvSpPr txBox="1"/>
+          <p:nvPr/>
+        </p:nvSpPr>
+        <p:spPr>
+          <a:xfrm>
+            <a:off x="521208" y="4270248"/>
+            <a:ext cx="8101584" cy="420624"/>
           </a:xfrm>
           <a:prstGeom prst="rect">
             <a:avLst/>
@@ -6341,7 +6380,7 @@
           <a:bodyPr wrap="square" lIns="0" tIns="0" rIns="0" bIns="0" rtlCol="0" anchor="ctr"/>
           <a:lstStyle/>
           <a:p>
-            <a:pPr marL="0" indent="0">
+            <a:pPr indent="0" marL="0">
               <a:buNone/>
             </a:pPr>
             <a:r>
@@ -6355,6 +6394,9 @@
               </a:rPr>
               <a:t>Ausschnitt: </a:t>
             </a:r>
+            <a:pPr indent="0" marL="0">
+              <a:buNone/>
+            </a:pPr>
             <a:r>
               <a:rPr lang="en-US" sz="850" dirty="0">
                 <a:solidFill>
@@ -6366,6 +6408,9 @@
               </a:rPr>
               <a:t>nur US 4.1.1.   </a:t>
             </a:r>
+            <a:pPr indent="0" marL="0">
+              <a:buNone/>
+            </a:pPr>
             <a:r>
               <a:rPr lang="en-US" sz="850" b="1" dirty="0">
                 <a:solidFill>
@@ -6377,6 +6422,9 @@
               </a:rPr>
               <a:t>Davor: </a:t>
             </a:r>
+            <a:pPr indent="0" marL="0">
+              <a:buNone/>
+            </a:pPr>
             <a:r>
               <a:rPr lang="en-US" sz="850" dirty="0">
                 <a:solidFill>
@@ -6386,8 +6434,11 @@
                 <a:ea typeface="Calibri" pitchFamily="34" charset="-122"/>
                 <a:cs typeface="Calibri" pitchFamily="34" charset="-120"/>
               </a:rPr>
-              <a:t>Entscheidung des Prüfungsausschusses (User Task 3.2).   </a:t>
-            </a:r>
+              <a:t>Studierende:r reicht den Antrag mit Thema ein (Activity 2).   </a:t>
+            </a:r>
+            <a:pPr indent="0" marL="0">
+              <a:buNone/>
+            </a:pPr>
             <a:r>
               <a:rPr lang="en-US" sz="850" b="1" dirty="0">
                 <a:solidFill>
@@ -6399,6 +6450,9 @@
               </a:rPr>
               <a:t>Danach: </a:t>
             </a:r>
+            <a:pPr indent="0" marL="0">
+              <a:buNone/>
+            </a:pPr>
             <a:r>
               <a:rPr lang="en-US" sz="850" dirty="0">
                 <a:solidFill>

</xml_diff>